<commit_message>
Update deck with Aug 31 cutoff, chart changes, and meeting script
Recompute all deck numbers with an August 31 month-end cut (exclude September):
Portal Aug avg 0.9 d / 85% same-day; Tesorio 50 completed / 4 open at month-end.
Swap the priority chart for invoices-by-portal (platform usage), show the
resolution distribution as percentages, and add English speaker notes to both
slides. Add an English meeting script covering the team's work, the metrics,
and the URL-access opportunity.

Co-Authored-By: Claude Opus 4.8 <noreply@anthropic.com>
Claude-Session: https://claude.ai/code/session_01Nn9QKEstPX9eZ4ngSPWHBW
</commit_message>
<xml_diff>
--- a/Portal_Metrics_Monthly_Aug-26.pptx
+++ b/Portal_Metrics_Monthly_Aug-26.pptx
@@ -134,7 +134,7 @@
                 </a:solidFill>
                 <a:latin typeface="Calibri"/>
               </a:rPr>
-              <a:t>Resolution distribution</a:t>
+              <a:t>Resolution distribution (%)</a:t>
             </a:r>
           </a:p>
         </c:rich>
@@ -227,7 +227,7 @@
           <c:dLbls>
             <c:dLbl>
               <c:idx val="0"/>
-              <c:numFmt formatCode="General" sourceLinked="0"/>
+              <c:numFmt formatCode="0%" sourceLinked="0"/>
               <c:spPr/>
               <c:txPr>
                 <a:bodyPr/>
@@ -244,15 +244,15 @@
                 </a:p>
               </c:txPr>
               <c:showLegendKey val="0"/>
-              <c:showVal val="1"/>
+              <c:showVal val="0"/>
               <c:showCatName val="0"/>
               <c:showSerName val="0"/>
-              <c:showPercent val="0"/>
+              <c:showPercent val="1"/>
               <c:showBubbleSize val="0"/>
             </c:dLbl>
             <c:dLbl>
               <c:idx val="1"/>
-              <c:numFmt formatCode="General" sourceLinked="0"/>
+              <c:numFmt formatCode="0%" sourceLinked="0"/>
               <c:spPr/>
               <c:txPr>
                 <a:bodyPr/>
@@ -269,15 +269,15 @@
                 </a:p>
               </c:txPr>
               <c:showLegendKey val="0"/>
-              <c:showVal val="1"/>
+              <c:showVal val="0"/>
               <c:showCatName val="0"/>
               <c:showSerName val="0"/>
-              <c:showPercent val="0"/>
+              <c:showPercent val="1"/>
               <c:showBubbleSize val="0"/>
             </c:dLbl>
             <c:dLbl>
               <c:idx val="2"/>
-              <c:numFmt formatCode="General" sourceLinked="0"/>
+              <c:numFmt formatCode="0%" sourceLinked="0"/>
               <c:spPr/>
               <c:txPr>
                 <a:bodyPr/>
@@ -294,15 +294,15 @@
                 </a:p>
               </c:txPr>
               <c:showLegendKey val="0"/>
-              <c:showVal val="1"/>
+              <c:showVal val="0"/>
               <c:showCatName val="0"/>
               <c:showSerName val="0"/>
-              <c:showPercent val="0"/>
+              <c:showPercent val="1"/>
               <c:showBubbleSize val="0"/>
             </c:dLbl>
             <c:dLbl>
               <c:idx val="3"/>
-              <c:numFmt formatCode="General" sourceLinked="0"/>
+              <c:numFmt formatCode="0%" sourceLinked="0"/>
               <c:spPr/>
               <c:txPr>
                 <a:bodyPr/>
@@ -319,15 +319,15 @@
                 </a:p>
               </c:txPr>
               <c:showLegendKey val="0"/>
-              <c:showVal val="1"/>
+              <c:showVal val="0"/>
               <c:showCatName val="0"/>
               <c:showSerName val="0"/>
-              <c:showPercent val="0"/>
+              <c:showPercent val="1"/>
               <c:showBubbleSize val="0"/>
             </c:dLbl>
             <c:dLbl>
               <c:idx val="4"/>
-              <c:numFmt formatCode="General" sourceLinked="0"/>
+              <c:numFmt formatCode="0%" sourceLinked="0"/>
               <c:spPr/>
               <c:txPr>
                 <a:bodyPr/>
@@ -344,13 +344,13 @@
                 </a:p>
               </c:txPr>
               <c:showLegendKey val="0"/>
-              <c:showVal val="1"/>
+              <c:showVal val="0"/>
               <c:showCatName val="0"/>
               <c:showSerName val="0"/>
-              <c:showPercent val="0"/>
+              <c:showPercent val="1"/>
               <c:showBubbleSize val="0"/>
             </c:dLbl>
-            <c:numFmt formatCode="General" sourceLinked="0"/>
+            <c:numFmt formatCode="0%" sourceLinked="0"/>
             <c:txPr>
               <a:bodyPr/>
               <a:lstStyle/>
@@ -414,7 +414,7 @@
                   <c:v>1</c:v>
                 </c:pt>
                 <c:pt idx="4">
-                  <c:v>3</c:v>
+                  <c:v>2</c:v>
                 </c:pt>
               </c:numCache>
             </c:numRef>
@@ -479,7 +479,7 @@
           <a:lstStyle/>
           <a:p>
             <a:pPr>
-              <a:defRPr sz="1300" b="0" i="0" u="none" strike="noStrike">
+              <a:defRPr sz="1200" b="0" i="0" u="none" strike="noStrike">
                 <a:solidFill>
                   <a:srgbClr val="158158"/>
                 </a:solidFill>
@@ -487,13 +487,13 @@
               </a:defRPr>
             </a:pPr>
             <a:r>
-              <a:rPr sz="1300" b="0" i="0" u="none" strike="noStrike">
+              <a:rPr sz="1200" b="0" i="0" u="none" strike="noStrike">
                 <a:solidFill>
                   <a:srgbClr val="158158"/>
                 </a:solidFill>
                 <a:latin typeface="Calibri"/>
               </a:rPr>
-              <a:t>Avg. days by priority</a:t>
+              <a:t>Invoices by portal (platforms we use most)</a:t>
             </a:r>
           </a:p>
         </c:rich>
@@ -505,7 +505,7 @@
     <c:plotArea>
       <c:layout/>
       <c:barChart>
-        <c:barDir val="col"/>
+        <c:barDir val="bar"/>
         <c:grouping val="clustered"/>
         <c:varyColors val="0"/>
         <c:ser>
@@ -517,14 +517,14 @@
               <c:strCache>
                 <c:ptCount val="1"/>
                 <c:pt idx="0">
-                  <c:v>Avg. days</c:v>
+                  <c:v>Invoices</c:v>
                 </c:pt>
               </c:strCache>
             </c:strRef>
           </c:tx>
           <c:spPr>
             <a:solidFill>
-              <a:srgbClr val="ED8B1B"/>
+              <a:srgbClr val="158158"/>
             </a:solidFill>
             <a:effectLst/>
           </c:spPr>
@@ -555,18 +555,27 @@
           </c:dLbls>
           <c:cat>
             <c:multiLvlStrRef>
-              <c:f>Sheet1!$A$2:$A$4</c:f>
+              <c:f>Sheet1!$A$2:$A$7</c:f>
               <c:multiLvlStrCache>
-                <c:ptCount val="3"/>
+                <c:ptCount val="6"/>
                 <c:lvl>
                   <c:pt idx="0">
-                    <c:v>Urgent</c:v>
+                    <c:v>Coupa</c:v>
                   </c:pt>
                   <c:pt idx="1">
-                    <c:v>High</c:v>
+                    <c:v>Ariba</c:v>
                   </c:pt>
                   <c:pt idx="2">
-                    <c:v>Normal</c:v>
+                    <c:v>Other</c:v>
+                  </c:pt>
+                  <c:pt idx="3">
+                    <c:v>Taulia</c:v>
+                  </c:pt>
+                  <c:pt idx="4">
+                    <c:v>Oracle</c:v>
+                  </c:pt>
+                  <c:pt idx="5">
+                    <c:v>URL</c:v>
                   </c:pt>
                 </c:lvl>
               </c:multiLvlStrCache>
@@ -574,18 +583,27 @@
           </c:cat>
           <c:val>
             <c:numRef>
-              <c:f>Sheet1!$B$2:$B$4</c:f>
+              <c:f>Sheet1!$B$2:$B$7</c:f>
               <c:numCache>
                 <c:formatCode>General</c:formatCode>
-                <c:ptCount val="3"/>
+                <c:ptCount val="6"/>
                 <c:pt idx="0">
-                  <c:v>0.9</c:v>
+                  <c:v>20</c:v>
                 </c:pt>
                 <c:pt idx="1">
-                  <c:v>5.9</c:v>
+                  <c:v>12</c:v>
                 </c:pt>
                 <c:pt idx="2">
-                  <c:v>0.8</c:v>
+                  <c:v>5</c:v>
+                </c:pt>
+                <c:pt idx="3">
+                  <c:v>4</c:v>
+                </c:pt>
+                <c:pt idx="4">
+                  <c:v>3</c:v>
+                </c:pt>
+                <c:pt idx="5">
+                  <c:v>2</c:v>
                 </c:pt>
               </c:numCache>
             </c:numRef>
@@ -627,11 +645,11 @@
           <c:orientation val="minMax"/>
         </c:scaling>
         <c:delete val="0"/>
-        <c:axPos val="b"/>
+        <c:axPos val="l"/>
         <c:numFmt formatCode="General" sourceLinked="1"/>
         <c:majorTickMark val="out"/>
         <c:minorTickMark val="none"/>
-        <c:tickLblPos val="low"/>
+        <c:tickLblPos val="nextTo"/>
         <c:spPr>
           <a:ln w="12700" cap="flat">
             <a:solidFill>
@@ -667,23 +685,12 @@
         <c:scaling>
           <c:orientation val="minMax"/>
         </c:scaling>
-        <c:delete val="0"/>
-        <c:axPos val="l"/>
-        <c:majorGridlines>
-          <c:spPr>
-            <a:ln w="12700" cap="flat">
-              <a:solidFill>
-                <a:srgbClr val="E5E5E5"/>
-              </a:solidFill>
-              <a:prstDash val="solid"/>
-              <a:round/>
-            </a:ln>
-          </c:spPr>
-        </c:majorGridlines>
+        <c:delete val="1"/>
+        <c:axPos val="b"/>
         <c:numFmt formatCode="General" sourceLinked="0"/>
         <c:majorTickMark val="out"/>
         <c:minorTickMark val="none"/>
-        <c:tickLblPos val="nextTo"/>
+        <c:tickLblPos val="low"/>
         <c:spPr>
           <a:ln w="12700" cap="flat">
             <a:solidFill>
@@ -698,11 +705,11 @@
           <a:lstStyle/>
           <a:p>
             <a:pPr>
-              <a:defRPr sz="900" b="0" i="0" u="none" strike="noStrike">
+              <a:defRPr sz="1200" b="0" i="0" u="none" strike="noStrike">
                 <a:solidFill>
-                  <a:srgbClr val="6B7B84"/>
+                  <a:srgbClr val="000000"/>
                 </a:solidFill>
-                <a:latin typeface="Calibri"/>
+                <a:latin typeface="Arial"/>
               </a:defRPr>
             </a:pPr>
             <a:endParaRPr lang="en-US"/>
@@ -1131,7 +1138,11 @@
           <a:p>
             <a:r>
               <a:rPr lang="en-US" dirty="0"/>
-              <a:t/>
+              <a:t>Portal Uploads — this is the whole team's work: submitting our clients' invoices across every customer portal.
+In August we handled 46 upload requests and resolved 41 of them, at an average of under one day (0.9) and 85% resolved the same day.
+The month-by-month table shows the trend: we went from ~2.8 days in June to under a day in August — a clear, steady improvement.
+The donut shows how fast we close them: about 85% are done same-day, and only a small tail takes longer.
+Numbers are cut off at August 31 — September is not included.</a:t>
             </a:r>
             <a:endParaRPr lang="en-US" dirty="0"/>
           </a:p>
@@ -1219,7 +1230,11 @@
           <a:p>
             <a:r>
               <a:rPr lang="en-US" dirty="0"/>
-              <a:t/>
+              <a:t>Tesorio Tasks is how we track that same portal work end to end. In August we completed 50 tasks at 1.1 days on average, 74% same-day, and only 4 were still open at month-end.
+The bar chart shows which platforms we use most: Coupa and Ariba carry the bulk of our volume, followed by Taulia and Oracle.
+Key insight and opportunity: the tasks that take the longest are the ones that come in as a raw URL, not through the portals we already use — those averaged about 8 days versus under 1 day for Coupa or Ariba.
+So our area of opportunity is access setup for those URL cases — if we can get proper portal access or credentials up front, we can close that gap.
+Cut off at August 31 — September excluded.</a:t>
             </a:r>
             <a:endParaRPr lang="en-US" dirty="0"/>
           </a:p>
@@ -1863,7 +1878,7 @@
                 <a:ea typeface="Calibri" pitchFamily="34" charset="-122"/>
                 <a:cs typeface="Calibri" pitchFamily="34" charset="-120"/>
               </a:rPr>
-              <a:t>42</a:t>
+              <a:t>41</a:t>
             </a:r>
             <a:endParaRPr lang="en-US" sz="2800" dirty="0"/>
           </a:p>
@@ -1963,7 +1978,7 @@
                 <a:ea typeface="Calibri" pitchFamily="34" charset="-122"/>
                 <a:cs typeface="Calibri" pitchFamily="34" charset="-120"/>
               </a:rPr>
-              <a:t>1.3 d</a:t>
+              <a:t>0.9 d</a:t>
             </a:r>
             <a:endParaRPr lang="en-US" sz="2800" dirty="0"/>
           </a:p>
@@ -2063,7 +2078,7 @@
                 <a:ea typeface="Calibri" pitchFamily="34" charset="-122"/>
                 <a:cs typeface="Calibri" pitchFamily="34" charset="-120"/>
               </a:rPr>
-              <a:t>83%</a:t>
+              <a:t>85%</a:t>
             </a:r>
             <a:endParaRPr lang="en-US" sz="2800" dirty="0"/>
           </a:p>
@@ -3356,7 +3371,7 @@
                           <a:ea typeface="Calibri" pitchFamily="34" charset="-122"/>
                           <a:cs typeface="Calibri" pitchFamily="34" charset="-120"/>
                         </a:rPr>
-                        <a:t>42</a:t>
+                        <a:t>41</a:t>
                       </a:r>
                       <a:endParaRPr lang="en-US" sz="1100" dirty="0">
                         <a:latin typeface="Calibri" charset="0"/>
@@ -3424,7 +3439,7 @@
                           <a:ea typeface="Calibri" pitchFamily="34" charset="-122"/>
                           <a:cs typeface="Calibri" pitchFamily="34" charset="-120"/>
                         </a:rPr>
-                        <a:t>1.3</a:t>
+                        <a:t>0.9</a:t>
                       </a:r>
                       <a:endParaRPr lang="en-US" sz="1100" dirty="0">
                         <a:latin typeface="Calibri" charset="0"/>
@@ -3492,7 +3507,7 @@
                           <a:ea typeface="Calibri" pitchFamily="34" charset="-122"/>
                           <a:cs typeface="Calibri" pitchFamily="34" charset="-120"/>
                         </a:rPr>
-                        <a:t>83%</a:t>
+                        <a:t>85%</a:t>
                       </a:r>
                       <a:endParaRPr lang="en-US" sz="1100" dirty="0">
                         <a:latin typeface="Calibri" charset="0"/>
@@ -3767,7 +3782,7 @@
                 <a:ea typeface="Calibri" pitchFamily="34" charset="-122"/>
                 <a:cs typeface="Calibri" pitchFamily="34" charset="-120"/>
               </a:rPr>
-              <a:t>51</a:t>
+              <a:t>50</a:t>
             </a:r>
             <a:endParaRPr lang="en-US" sz="2800" dirty="0"/>
           </a:p>
@@ -3967,7 +3982,7 @@
                 <a:ea typeface="Calibri" pitchFamily="34" charset="-122"/>
                 <a:cs typeface="Calibri" pitchFamily="34" charset="-120"/>
               </a:rPr>
-              <a:t>75%</a:t>
+              <a:t>74%</a:t>
             </a:r>
             <a:endParaRPr lang="en-US" sz="2800" dirty="0"/>
           </a:p>
@@ -4067,7 +4082,7 @@
                 <a:ea typeface="Calibri" pitchFamily="34" charset="-122"/>
                 <a:cs typeface="Calibri" pitchFamily="34" charset="-120"/>
               </a:rPr>
-              <a:t>9</a:t>
+              <a:t>4</a:t>
             </a:r>
             <a:endParaRPr lang="en-US" sz="2800" dirty="0"/>
           </a:p>
@@ -4106,7 +4121,7 @@
                 <a:ea typeface="Calibri" pitchFamily="34" charset="-122"/>
                 <a:cs typeface="Calibri" pitchFamily="34" charset="-120"/>
               </a:rPr>
-              <a:t>Open today</a:t>
+              <a:t>Open (Aug 31)</a:t>
             </a:r>
             <a:endParaRPr lang="en-US" sz="1100" dirty="0"/>
           </a:p>
@@ -4950,7 +4965,7 @@
                           <a:ea typeface="Calibri" pitchFamily="34" charset="-122"/>
                           <a:cs typeface="Calibri" pitchFamily="34" charset="-120"/>
                         </a:rPr>
-                        <a:t>78</a:t>
+                        <a:t>80</a:t>
                       </a:r>
                       <a:endParaRPr lang="en-US" sz="1100" dirty="0">
                         <a:latin typeface="Calibri" charset="0"/>
@@ -5360,7 +5375,7 @@
                           <a:ea typeface="Calibri" pitchFamily="34" charset="-122"/>
                           <a:cs typeface="Calibri" pitchFamily="34" charset="-120"/>
                         </a:rPr>
-                        <a:t>51</a:t>
+                        <a:t>50</a:t>
                       </a:r>
                       <a:endParaRPr lang="en-US" sz="1100" dirty="0">
                         <a:latin typeface="Calibri" charset="0"/>
@@ -5496,7 +5511,7 @@
                           <a:ea typeface="Calibri" pitchFamily="34" charset="-122"/>
                           <a:cs typeface="Calibri" pitchFamily="34" charset="-120"/>
                         </a:rPr>
-                        <a:t>75%</a:t>
+                        <a:t>74%</a:t>
                       </a:r>
                       <a:endParaRPr lang="en-US" sz="1100" dirty="0">
                         <a:latin typeface="Calibri" charset="0"/>

</xml_diff>

<commit_message>
Tailor meeting script to Collections team and add "what this means"
Address the Collections team, keep the script to ~2 minutes, and add a "what
this means for us" section tying resolution speed to client cash flow and
experience. Mirror the framing in the deck's slide-2 speaker notes.

Co-Authored-By: Claude Opus 4.8 <noreply@anthropic.com>
Claude-Session: https://claude.ai/code/session_01Nn9QKEstPX9eZ4ngSPWHBW
</commit_message>
<xml_diff>
--- a/Portal_Metrics_Monthly_Aug-26.pptx
+++ b/Portal_Metrics_Monthly_Aug-26.pptx
@@ -1232,8 +1232,8 @@
               <a:rPr lang="en-US" dirty="0"/>
               <a:t>Tesorio Tasks is how we track that same portal work end to end. In August we completed 50 tasks at 1.1 days on average, 74% same-day, and only 4 were still open at month-end.
 The bar chart shows which platforms we use most: Coupa and Ariba carry the bulk of our volume, followed by Taulia and Oracle.
-Key insight and opportunity: the tasks that take the longest are the ones that come in as a raw URL, not through the portals we already use — those averaged about 8 days versus under 1 day for Coupa or Ariba.
-So our area of opportunity is access setup for those URL cases — if we can get proper portal access or credentials up front, we can close that gap.
+Area of opportunity: the slowest cases are the ones that come in as a raw URL, not the portals we already use — about 8 days versus under 1 day for Coupa or Ariba. If we can get proper access or credentials up front for those, we close the gap.
+What this means for us: every upload is an invoice a client is waiting to get paid on. Going from three days to under a day means clients get paid faster, fewer escalations, less friction. Speed here protects the client's cash flow and experience — it's how Collections shows up for them, and this month the team did it really well.
 Cut off at August 31 — September excluded.</a:t>
             </a:r>
             <a:endParaRPr lang="en-US" dirty="0"/>

</xml_diff>